<commit_message>
Upgrade midterm deck with real data findings.
Updates the presentation outline and generated deck to cover the grading rubric, including real Lending Club analysis, progress status, Gantt timeline, risks, and next steps.

Co-Authored-By: Claude Opus 4.7 <noreply@anthropic.com>
</commit_message>
<xml_diff>
--- a/slides/midterm_report.pptx
+++ b/slides/midterm_report.pptx
@@ -15,6 +15,10 @@
     <p:sldId id="266" r:id="rId11"/>
     <p:sldId id="267" r:id="rId12"/>
     <p:sldId id="268" r:id="rId13"/>
+    <p:sldId id="269" r:id="rId14"/>
+    <p:sldId id="270" r:id="rId15"/>
+    <p:sldId id="271" r:id="rId16"/>
+    <p:sldId id="272" r:id="rId17"/>
   </p:sldIdLst>
   <p:sldSz cx="12192000" cy="6858000" type="wide"/>
   <p:notesSz cx="6858000" cy="9144000"/>
@@ -214,7 +218,7 @@
                 <a:latin typeface="Arial"/>
                 <a:ea typeface="Microsoft YaHei"/>
               </a:rPr>
-              <a:t>样例结果：州级违约风险</a:t>
+              <a:t>真实发现 3：FICO 与违约率</a:t>
             </a:r>
           </a:p>
         </p:txBody>
@@ -250,37 +254,37 @@
                 <a:latin typeface="Arial"/>
                 <a:ea typeface="Microsoft YaHei"/>
               </a:rPr>
-              <a:t>按州聚合样例贷款数量与违约率。</a:t>
-            </a:r>
-          </a:p>
-          <a:p>
-            <a:pPr marL="342900" indent="-171450">
-              <a:buChar char="•"/>
-            </a:pPr>
-            <a:r>
-              <a:rPr lang="zh-CN" sz="2000">
-                <a:solidFill>
-                  <a:srgbClr val="374151"/>
-                </a:solidFill>
-                <a:latin typeface="Arial"/>
-                <a:ea typeface="Microsoft YaHei"/>
-              </a:rPr>
-              <a:t>使用 SQLite SQL 完成州级统计。</a:t>
-            </a:r>
-          </a:p>
-          <a:p>
-            <a:pPr marL="342900" indent="-171450">
-              <a:buChar char="•"/>
-            </a:pPr>
-            <a:r>
-              <a:rPr lang="zh-CN" sz="2000">
-                <a:solidFill>
-                  <a:srgbClr val="374151"/>
-                </a:solidFill>
-                <a:latin typeface="Arial"/>
-                <a:ea typeface="Microsoft YaHei"/>
-              </a:rPr>
-              <a:t>后续将接入 ACS 收入、贫困率、失业率等真实区域变量。</a:t>
+              <a:t>FICO 分数越低，违约率通常越高。</a:t>
+            </a:r>
+          </a:p>
+          <a:p>
+            <a:pPr marL="342900" indent="-171450">
+              <a:buChar char="•"/>
+            </a:pPr>
+            <a:r>
+              <a:rPr lang="zh-CN" sz="2000">
+                <a:solidFill>
+                  <a:srgbClr val="374151"/>
+                </a:solidFill>
+                <a:latin typeface="Arial"/>
+                <a:ea typeface="Microsoft YaHei"/>
+              </a:rPr>
+              <a:t>传统信用评分仍有明显解释力。</a:t>
+            </a:r>
+          </a:p>
+          <a:p>
+            <a:pPr marL="342900" indent="-171450">
+              <a:buChar char="•"/>
+            </a:pPr>
+            <a:r>
+              <a:rPr lang="zh-CN" sz="2000">
+                <a:solidFill>
+                  <a:srgbClr val="374151"/>
+                </a:solidFill>
+                <a:latin typeface="Arial"/>
+                <a:ea typeface="Microsoft YaHei"/>
+              </a:rPr>
+              <a:t>多源数据的价值不是替代 FICO，而是补充地区经济和宏观环境信息。</a:t>
             </a:r>
           </a:p>
         </p:txBody>
@@ -360,7 +364,7 @@
                 <a:latin typeface="Arial"/>
                 <a:ea typeface="Microsoft YaHei"/>
               </a:rPr>
-              <a:t>风险与备选方案</a:t>
+              <a:t>真实发现 4：时间趋势</a:t>
             </a:r>
           </a:p>
         </p:txBody>
@@ -374,78 +378,85 @@
         <p:spPr>
           <a:xfrm>
             <a:off x="685800" y="1143000"/>
-            <a:ext cx="10607040" cy="4389120"/>
-          </a:xfrm>
-          <a:prstGeom prst="rect">
-            <a:avLst/>
-          </a:prstGeom>
-          <a:noFill/>
-        </p:spPr>
-        <p:txBody>
-          <a:bodyPr wrap="square"/>
-          <a:lstStyle/>
-          <a:p>
-            <a:pPr marL="342900" indent="-171450">
-              <a:buChar char="•"/>
-            </a:pPr>
-            <a:r>
-              <a:rPr lang="zh-CN" sz="2000">
-                <a:solidFill>
-                  <a:srgbClr val="374151"/>
-                </a:solidFill>
-                <a:latin typeface="Arial"/>
-                <a:ea typeface="Microsoft YaHei"/>
-              </a:rPr>
-              <a:t>Kaggle 数据下载慢：先展示样例流程，下载后补跑。</a:t>
-            </a:r>
-          </a:p>
-          <a:p>
-            <a:pPr marL="342900" indent="-171450">
-              <a:buChar char="•"/>
-            </a:pPr>
-            <a:r>
-              <a:rPr lang="zh-CN" sz="2000">
-                <a:solidFill>
-                  <a:srgbClr val="374151"/>
-                </a:solidFill>
-                <a:latin typeface="Arial"/>
-                <a:ea typeface="Microsoft YaHei"/>
-              </a:rPr>
-              <a:t>数据量过大：先抽样分析，再保留抽样策略说明。</a:t>
-            </a:r>
-          </a:p>
-          <a:p>
-            <a:pPr marL="342900" indent="-171450">
-              <a:buChar char="•"/>
-            </a:pPr>
-            <a:r>
-              <a:rPr lang="zh-CN" sz="2000">
-                <a:solidFill>
-                  <a:srgbClr val="374151"/>
-                </a:solidFill>
-                <a:latin typeface="Arial"/>
-                <a:ea typeface="Microsoft YaHei"/>
-              </a:rPr>
-              <a:t>多源粒度不一致：降到州级、年度/季度级对齐。</a:t>
-            </a:r>
-          </a:p>
-          <a:p>
-            <a:pPr marL="342900" indent="-171450">
-              <a:buChar char="•"/>
-            </a:pPr>
-            <a:r>
-              <a:rPr lang="zh-CN" sz="2000">
-                <a:solidFill>
-                  <a:srgbClr val="374151"/>
-                </a:solidFill>
-                <a:latin typeface="Arial"/>
-                <a:ea typeface="Microsoft YaHei"/>
-              </a:rPr>
-              <a:t>模型效果不明显：强调解释性分析和多源变量贡献。</a:t>
-            </a:r>
-          </a:p>
-        </p:txBody>
-      </p:sp>
+            <a:ext cx="5486400" cy="4389120"/>
+          </a:xfrm>
+          <a:prstGeom prst="rect">
+            <a:avLst/>
+          </a:prstGeom>
+          <a:noFill/>
+        </p:spPr>
+        <p:txBody>
+          <a:bodyPr wrap="square"/>
+          <a:lstStyle/>
+          <a:p>
+            <a:pPr marL="342900" indent="-171450">
+              <a:buChar char="•"/>
+            </a:pPr>
+            <a:r>
+              <a:rPr lang="zh-CN" sz="2000">
+                <a:solidFill>
+                  <a:srgbClr val="374151"/>
+                </a:solidFill>
+                <a:latin typeface="Arial"/>
+                <a:ea typeface="Microsoft YaHei"/>
+              </a:rPr>
+              <a:t>按发放年份统计违约率，可以观察不同信贷周期下的风险变化。</a:t>
+            </a:r>
+          </a:p>
+          <a:p>
+            <a:pPr marL="342900" indent="-171450">
+              <a:buChar char="•"/>
+            </a:pPr>
+            <a:r>
+              <a:rPr lang="zh-CN" sz="2000">
+                <a:solidFill>
+                  <a:srgbClr val="374151"/>
+                </a:solidFill>
+                <a:latin typeface="Arial"/>
+                <a:ea typeface="Microsoft YaHei"/>
+              </a:rPr>
+              <a:t>后续将与 Fed 利率、通胀、失业率做年度/季度级对齐。</a:t>
+            </a:r>
+          </a:p>
+          <a:p>
+            <a:pPr marL="342900" indent="-171450">
+              <a:buChar char="•"/>
+            </a:pPr>
+            <a:r>
+              <a:rPr lang="zh-CN" sz="2000">
+                <a:solidFill>
+                  <a:srgbClr val="374151"/>
+                </a:solidFill>
+                <a:latin typeface="Arial"/>
+                <a:ea typeface="Microsoft YaHei"/>
+              </a:rPr>
+              <a:t>目标：解释宏观环境是否能解释时间维度的风险波动。</a:t>
+            </a:r>
+          </a:p>
+        </p:txBody>
+      </p:sp>
+      <p:pic>
+        <p:nvPicPr>
+          <p:cNvPr id="4" name="Picture 4"/>
+          <p:cNvPicPr/>
+          <p:nvPr/>
+        </p:nvPicPr>
+        <p:blipFill>
+          <a:blip r:embed="rId2"/>
+          <a:stretch>
+            <a:fillRect/>
+          </a:stretch>
+        </p:blipFill>
+        <p:spPr>
+          <a:xfrm>
+            <a:off x="6309360" y="1325880"/>
+            <a:ext cx="5120640" cy="3108960"/>
+          </a:xfrm>
+          <a:prstGeom prst="rect">
+            <a:avLst/>
+          </a:prstGeom>
+        </p:spPr>
+      </p:pic>
     </p:spTree>
   </p:cSld>
   <p:clrMapOvr>
@@ -499,7 +510,7 @@
                 <a:latin typeface="Arial"/>
                 <a:ea typeface="Microsoft YaHei"/>
               </a:rPr>
-              <a:t>后续计划</a:t>
+              <a:t>真实发现 5：州级差异</a:t>
             </a:r>
           </a:p>
         </p:txBody>
@@ -513,93 +524,85 @@
         <p:spPr>
           <a:xfrm>
             <a:off x="685800" y="1143000"/>
-            <a:ext cx="10607040" cy="4389120"/>
-          </a:xfrm>
-          <a:prstGeom prst="rect">
-            <a:avLst/>
-          </a:prstGeom>
-          <a:noFill/>
-        </p:spPr>
-        <p:txBody>
-          <a:bodyPr wrap="square"/>
-          <a:lstStyle/>
-          <a:p>
-            <a:pPr marL="342900" indent="-171450">
-              <a:buChar char="•"/>
-            </a:pPr>
-            <a:r>
-              <a:rPr lang="zh-CN" sz="2000">
-                <a:solidFill>
-                  <a:srgbClr val="374151"/>
-                </a:solidFill>
-                <a:latin typeface="Arial"/>
-                <a:ea typeface="Microsoft YaHei"/>
-              </a:rPr>
-              <a:t>5/22–5/26：下载 Lending Club / Home Credit，完成字段筛选和基础清洗。</a:t>
-            </a:r>
-          </a:p>
-          <a:p>
-            <a:pPr marL="342900" indent="-171450">
-              <a:buChar char="•"/>
-            </a:pPr>
-            <a:r>
-              <a:rPr lang="zh-CN" sz="2000">
-                <a:solidFill>
-                  <a:srgbClr val="374151"/>
-                </a:solidFill>
-                <a:latin typeface="Arial"/>
-                <a:ea typeface="Microsoft YaHei"/>
-              </a:rPr>
-              <a:t>5/27–6/1：接入真实 ACS / Fed 数据，完成州级和时间级融合。</a:t>
-            </a:r>
-          </a:p>
-          <a:p>
-            <a:pPr marL="342900" indent="-171450">
-              <a:buChar char="•"/>
-            </a:pPr>
-            <a:r>
-              <a:rPr lang="zh-CN" sz="2000">
-                <a:solidFill>
-                  <a:srgbClr val="374151"/>
-                </a:solidFill>
-                <a:latin typeface="Arial"/>
-                <a:ea typeface="Microsoft YaHei"/>
-              </a:rPr>
-              <a:t>6/2–6/6：完成统计分析、可视化和单源/多源对比。</a:t>
-            </a:r>
-          </a:p>
-          <a:p>
-            <a:pPr marL="342900" indent="-171450">
-              <a:buChar char="•"/>
-            </a:pPr>
-            <a:r>
-              <a:rPr lang="zh-CN" sz="2000">
-                <a:solidFill>
-                  <a:srgbClr val="374151"/>
-                </a:solidFill>
-                <a:latin typeface="Arial"/>
-                <a:ea typeface="Microsoft YaHei"/>
-              </a:rPr>
-              <a:t>6/7–6/10：完成最终汇报 PPT 和展示材料。</a:t>
-            </a:r>
-          </a:p>
-          <a:p>
-            <a:pPr marL="342900" indent="-171450">
-              <a:buChar char="•"/>
-            </a:pPr>
-            <a:r>
-              <a:rPr lang="zh-CN" sz="2000">
-                <a:solidFill>
-                  <a:srgbClr val="374151"/>
-                </a:solidFill>
-                <a:latin typeface="Arial"/>
-                <a:ea typeface="Microsoft YaHei"/>
-              </a:rPr>
-              <a:t>6/11–6/17：完成最终报告、代码整理和演示视频。</a:t>
-            </a:r>
-          </a:p>
-        </p:txBody>
-      </p:sp>
+            <a:ext cx="5486400" cy="4389120"/>
+          </a:xfrm>
+          <a:prstGeom prst="rect">
+            <a:avLst/>
+          </a:prstGeom>
+          <a:noFill/>
+        </p:spPr>
+        <p:txBody>
+          <a:bodyPr wrap="square"/>
+          <a:lstStyle/>
+          <a:p>
+            <a:pPr marL="342900" indent="-171450">
+              <a:buChar char="•"/>
+            </a:pPr>
+            <a:r>
+              <a:rPr lang="zh-CN" sz="2000">
+                <a:solidFill>
+                  <a:srgbClr val="374151"/>
+                </a:solidFill>
+                <a:latin typeface="Arial"/>
+                <a:ea typeface="Microsoft YaHei"/>
+              </a:rPr>
+              <a:t>州级违约率存在明显地区差异。</a:t>
+            </a:r>
+          </a:p>
+          <a:p>
+            <a:pPr marL="342900" indent="-171450">
+              <a:buChar char="•"/>
+            </a:pPr>
+            <a:r>
+              <a:rPr lang="zh-CN" sz="2000">
+                <a:solidFill>
+                  <a:srgbClr val="374151"/>
+                </a:solidFill>
+                <a:latin typeface="Arial"/>
+                <a:ea typeface="Microsoft YaHei"/>
+              </a:rPr>
+              <a:t>样本量超过 1000 的州中，MS 违约率最高，约 28.37%。</a:t>
+            </a:r>
+          </a:p>
+          <a:p>
+            <a:pPr marL="342900" indent="-171450">
+              <a:buChar char="•"/>
+            </a:pPr>
+            <a:r>
+              <a:rPr lang="zh-CN" sz="2000">
+                <a:solidFill>
+                  <a:srgbClr val="374151"/>
+                </a:solidFill>
+                <a:latin typeface="Arial"/>
+                <a:ea typeface="Microsoft YaHei"/>
+              </a:rPr>
+              <a:t>后续将接入 ACS 收入、贫困率、就业等指标解释地区差异。</a:t>
+            </a:r>
+          </a:p>
+        </p:txBody>
+      </p:sp>
+      <p:pic>
+        <p:nvPicPr>
+          <p:cNvPr id="4" name="Picture 4"/>
+          <p:cNvPicPr/>
+          <p:nvPr/>
+        </p:nvPicPr>
+        <p:blipFill>
+          <a:blip r:embed="rId2"/>
+          <a:stretch>
+            <a:fillRect/>
+          </a:stretch>
+        </p:blipFill>
+        <p:spPr>
+          <a:xfrm>
+            <a:off x="6309360" y="1325880"/>
+            <a:ext cx="5120640" cy="3108960"/>
+          </a:xfrm>
+          <a:prstGeom prst="rect">
+            <a:avLst/>
+          </a:prstGeom>
+        </p:spPr>
+      </p:pic>
     </p:spTree>
   </p:cSld>
   <p:clrMapOvr>
@@ -653,7 +656,7 @@
                 <a:latin typeface="Arial"/>
                 <a:ea typeface="Microsoft YaHei"/>
               </a:rPr>
-              <a:t>小组分工与总结</a:t>
+              <a:t>哪些尝试奏效，哪些没有</a:t>
             </a:r>
           </a:p>
         </p:txBody>
@@ -689,67 +692,668 @@
                 <a:latin typeface="Arial"/>
                 <a:ea typeface="Microsoft YaHei"/>
               </a:rPr>
-              <a:t>成员 A：贷款数据获取与清洗。</a:t>
-            </a:r>
-          </a:p>
-          <a:p>
-            <a:pPr marL="342900" indent="-171450">
-              <a:buChar char="•"/>
-            </a:pPr>
-            <a:r>
-              <a:rPr lang="zh-CN" sz="2000">
-                <a:solidFill>
-                  <a:srgbClr val="374151"/>
-                </a:solidFill>
-                <a:latin typeface="Arial"/>
-                <a:ea typeface="Microsoft YaHei"/>
-              </a:rPr>
-              <a:t>成员 B：外部数据与多源融合。</a:t>
-            </a:r>
-          </a:p>
-          <a:p>
-            <a:pPr marL="342900" indent="-171450">
-              <a:buChar char="•"/>
-            </a:pPr>
-            <a:r>
-              <a:rPr lang="zh-CN" sz="2000">
-                <a:solidFill>
-                  <a:srgbClr val="374151"/>
-                </a:solidFill>
-                <a:latin typeface="Arial"/>
-                <a:ea typeface="Microsoft YaHei"/>
-              </a:rPr>
-              <a:t>成员 C：可视化、汇报与答辩准备。</a:t>
-            </a:r>
-          </a:p>
-          <a:p>
-            <a:pPr marL="342900" indent="-171450">
-              <a:buChar char="•"/>
-            </a:pPr>
-            <a:r>
-              <a:rPr lang="zh-CN" sz="2000">
-                <a:solidFill>
-                  <a:srgbClr val="374151"/>
-                </a:solidFill>
-                <a:latin typeface="Arial"/>
-                <a:ea typeface="Microsoft YaHei"/>
-              </a:rPr>
-              <a:t>中期已完成项目骨架、样例多源融合流水线和可展示图表。</a:t>
-            </a:r>
-          </a:p>
-          <a:p>
-            <a:pPr marL="342900" indent="-171450">
-              <a:buChar char="•"/>
-            </a:pPr>
-            <a:r>
-              <a:rPr lang="zh-CN" sz="2000">
-                <a:solidFill>
-                  <a:srgbClr val="374151"/>
-                </a:solidFill>
-                <a:latin typeface="Arial"/>
-                <a:ea typeface="Microsoft YaHei"/>
-              </a:rPr>
-              <a:t>下一阶段重点是接入真实数据并形成可靠结论。</a:t>
+              <a:t>奏效：Lending Club 大型 CSV 已成功流式处理，避免一次性加载内存。</a:t>
+            </a:r>
+          </a:p>
+          <a:p>
+            <a:pPr marL="342900" indent="-171450">
+              <a:buChar char="•"/>
+            </a:pPr>
+            <a:r>
+              <a:rPr lang="zh-CN" sz="2000">
+                <a:solidFill>
+                  <a:srgbClr val="374151"/>
+                </a:solidFill>
+                <a:latin typeface="Arial"/>
+                <a:ea typeface="Microsoft YaHei"/>
+              </a:rPr>
+              <a:t>奏效：贷款状态过滤避免把 Current 等未完结状态误判为不违约。</a:t>
+            </a:r>
+          </a:p>
+          <a:p>
+            <a:pPr marL="342900" indent="-171450">
+              <a:buChar char="•"/>
+            </a:pPr>
+            <a:r>
+              <a:rPr lang="zh-CN" sz="2000">
+                <a:solidFill>
+                  <a:srgbClr val="374151"/>
+                </a:solidFill>
+                <a:latin typeface="Arial"/>
+                <a:ea typeface="Microsoft YaHei"/>
+              </a:rPr>
+              <a:t>奏效：真实数据图表已可直接用于中期汇报。</a:t>
+            </a:r>
+          </a:p>
+          <a:p>
+            <a:pPr marL="342900" indent="-171450">
+              <a:buChar char="•"/>
+            </a:pPr>
+            <a:r>
+              <a:rPr lang="zh-CN" sz="2000">
+                <a:solidFill>
+                  <a:srgbClr val="374151"/>
+                </a:solidFill>
+                <a:latin typeface="Arial"/>
+                <a:ea typeface="Microsoft YaHei"/>
+              </a:rPr>
+              <a:t>受阻：Home Credit 需要先网页端接受 Kaggle competition rules。</a:t>
+            </a:r>
+          </a:p>
+          <a:p>
+            <a:pPr marL="342900" indent="-171450">
+              <a:buChar char="•"/>
+            </a:pPr>
+            <a:r>
+              <a:rPr lang="zh-CN" sz="2000">
+                <a:solidFill>
+                  <a:srgbClr val="374151"/>
+                </a:solidFill>
+                <a:latin typeface="Arial"/>
+                <a:ea typeface="Microsoft YaHei"/>
+              </a:rPr>
+              <a:t>待完成：ACS/Fed 真实外部数据尚未融合。</a:t>
+            </a:r>
+          </a:p>
+        </p:txBody>
+      </p:sp>
+    </p:spTree>
+  </p:cSld>
+  <p:clrMapOvr>
+    <a:masterClrMapping/>
+  </p:clrMapOvr>
+</p:sld>
+</file>
+
+<file path=ppt/slides/slide14.xml><?xml version="1.0" encoding="utf-8"?>
+<p:sld xmlns:a="http://schemas.openxmlformats.org/drawingml/2006/main" xmlns:r="http://schemas.openxmlformats.org/officeDocument/2006/relationships" xmlns:p="http://schemas.openxmlformats.org/presentationml/2006/main">
+  <p:cSld>
+    <p:spTree>
+      <p:nvGrpSpPr>
+        <p:cNvPr id="1" name=""/>
+        <p:cNvGrpSpPr/>
+        <p:nvPr/>
+      </p:nvGrpSpPr>
+      <p:grpSpPr>
+        <a:xfrm>
+          <a:off x="0" y="0"/>
+          <a:ext cx="0" cy="0"/>
+          <a:chOff x="0" y="0"/>
+          <a:chExt cx="0" cy="0"/>
+        </a:xfrm>
+      </p:grpSpPr>
+      <p:sp>
+        <p:nvSpPr>
+          <p:cNvPr id="2" name="TextBox 2"/>
+          <p:cNvSpPr txBox="1"/>
+          <p:nvPr/>
+        </p:nvSpPr>
+        <p:spPr>
+          <a:xfrm>
+            <a:off x="502920" y="292608"/>
+            <a:ext cx="11155680" cy="685800"/>
+          </a:xfrm>
+          <a:prstGeom prst="rect">
+            <a:avLst/>
+          </a:prstGeom>
+          <a:noFill/>
+        </p:spPr>
+        <p:txBody>
+          <a:bodyPr wrap="square"/>
+          <a:lstStyle/>
+          <a:p>
+            <a:r>
+              <a:rPr lang="zh-CN" sz="3000" b="1">
+                <a:solidFill>
+                  <a:srgbClr val="111827"/>
+                </a:solidFill>
+                <a:latin typeface="Arial"/>
+                <a:ea typeface="Microsoft YaHei"/>
+              </a:rPr>
+              <a:t>项目甘特图与当前节点</a:t>
+            </a:r>
+          </a:p>
+        </p:txBody>
+      </p:sp>
+      <p:sp>
+        <p:nvSpPr>
+          <p:cNvPr id="3" name="Bullets 3"/>
+          <p:cNvSpPr txBox="1"/>
+          <p:nvPr/>
+        </p:nvSpPr>
+        <p:spPr>
+          <a:xfrm>
+            <a:off x="685800" y="1143000"/>
+            <a:ext cx="10607040" cy="4389120"/>
+          </a:xfrm>
+          <a:prstGeom prst="rect">
+            <a:avLst/>
+          </a:prstGeom>
+          <a:noFill/>
+        </p:spPr>
+        <p:txBody>
+          <a:bodyPr wrap="square"/>
+          <a:lstStyle/>
+          <a:p>
+            <a:pPr marL="342900" indent="-171450">
+              <a:buChar char="•"/>
+            </a:pPr>
+            <a:r>
+              <a:rPr lang="zh-CN" sz="2000">
+                <a:solidFill>
+                  <a:srgbClr val="374151"/>
+                </a:solidFill>
+                <a:latin typeface="Arial"/>
+                <a:ea typeface="Microsoft YaHei"/>
+              </a:rPr>
+              <a:t>4/20–4/30：开题与问题定义 — 已完成。</a:t>
+            </a:r>
+          </a:p>
+          <a:p>
+            <a:pPr marL="342900" indent="-171450">
+              <a:buChar char="•"/>
+            </a:pPr>
+            <a:r>
+              <a:rPr lang="zh-CN" sz="2000">
+                <a:solidFill>
+                  <a:srgbClr val="374151"/>
+                </a:solidFill>
+                <a:latin typeface="Arial"/>
+                <a:ea typeface="Microsoft YaHei"/>
+              </a:rPr>
+              <a:t>5/15–5/18：项目仓库与数据说明 — 已完成。</a:t>
+            </a:r>
+          </a:p>
+          <a:p>
+            <a:pPr marL="342900" indent="-171450">
+              <a:buChar char="•"/>
+            </a:pPr>
+            <a:r>
+              <a:rPr lang="zh-CN" sz="2000">
+                <a:solidFill>
+                  <a:srgbClr val="374151"/>
+                </a:solidFill>
+                <a:latin typeface="Arial"/>
+                <a:ea typeface="Microsoft YaHei"/>
+              </a:rPr>
+              <a:t>5/18–5/19：Lending Club 下载与初步 EDA — 已完成，当前节点。</a:t>
+            </a:r>
+          </a:p>
+          <a:p>
+            <a:pPr marL="342900" indent="-171450">
+              <a:buChar char="•"/>
+            </a:pPr>
+            <a:r>
+              <a:rPr lang="zh-CN" sz="2000">
+                <a:solidFill>
+                  <a:srgbClr val="374151"/>
+                </a:solidFill>
+                <a:latin typeface="Arial"/>
+                <a:ea typeface="Microsoft YaHei"/>
+              </a:rPr>
+              <a:t>5/20–5/27：Home Credit / ACS / Fed 接入 — 进行中。</a:t>
+            </a:r>
+          </a:p>
+          <a:p>
+            <a:pPr marL="342900" indent="-171450">
+              <a:buChar char="•"/>
+            </a:pPr>
+            <a:r>
+              <a:rPr lang="zh-CN" sz="2000">
+                <a:solidFill>
+                  <a:srgbClr val="374151"/>
+                </a:solidFill>
+                <a:latin typeface="Arial"/>
+                <a:ea typeface="Microsoft YaHei"/>
+              </a:rPr>
+              <a:t>5/27–6/3：多源融合与对比分析 — 未开始。</a:t>
+            </a:r>
+          </a:p>
+          <a:p>
+            <a:pPr marL="342900" indent="-171450">
+              <a:buChar char="•"/>
+            </a:pPr>
+            <a:r>
+              <a:rPr lang="zh-CN" sz="2000">
+                <a:solidFill>
+                  <a:srgbClr val="374151"/>
+                </a:solidFill>
+                <a:latin typeface="Arial"/>
+                <a:ea typeface="Microsoft YaHei"/>
+              </a:rPr>
+              <a:t>6/3–6/17：最终可视化、报告、视频和提交 — 未开始。</a:t>
+            </a:r>
+          </a:p>
+        </p:txBody>
+      </p:sp>
+    </p:spTree>
+  </p:cSld>
+  <p:clrMapOvr>
+    <a:masterClrMapping/>
+  </p:clrMapOvr>
+</p:sld>
+</file>
+
+<file path=ppt/slides/slide15.xml><?xml version="1.0" encoding="utf-8"?>
+<p:sld xmlns:a="http://schemas.openxmlformats.org/drawingml/2006/main" xmlns:r="http://schemas.openxmlformats.org/officeDocument/2006/relationships" xmlns:p="http://schemas.openxmlformats.org/presentationml/2006/main">
+  <p:cSld>
+    <p:spTree>
+      <p:nvGrpSpPr>
+        <p:cNvPr id="1" name=""/>
+        <p:cNvGrpSpPr/>
+        <p:nvPr/>
+      </p:nvGrpSpPr>
+      <p:grpSpPr>
+        <a:xfrm>
+          <a:off x="0" y="0"/>
+          <a:ext cx="0" cy="0"/>
+          <a:chOff x="0" y="0"/>
+          <a:chExt cx="0" cy="0"/>
+        </a:xfrm>
+      </p:grpSpPr>
+      <p:sp>
+        <p:nvSpPr>
+          <p:cNvPr id="2" name="TextBox 2"/>
+          <p:cNvSpPr txBox="1"/>
+          <p:nvPr/>
+        </p:nvSpPr>
+        <p:spPr>
+          <a:xfrm>
+            <a:off x="502920" y="292608"/>
+            <a:ext cx="11155680" cy="685800"/>
+          </a:xfrm>
+          <a:prstGeom prst="rect">
+            <a:avLst/>
+          </a:prstGeom>
+          <a:noFill/>
+        </p:spPr>
+        <p:txBody>
+          <a:bodyPr wrap="square"/>
+          <a:lstStyle/>
+          <a:p>
+            <a:r>
+              <a:rPr lang="zh-CN" sz="3000" b="1">
+                <a:solidFill>
+                  <a:srgbClr val="111827"/>
+                </a:solidFill>
+                <a:latin typeface="Arial"/>
+                <a:ea typeface="Microsoft YaHei"/>
+              </a:rPr>
+              <a:t>后续计划</a:t>
+            </a:r>
+          </a:p>
+        </p:txBody>
+      </p:sp>
+      <p:sp>
+        <p:nvSpPr>
+          <p:cNvPr id="3" name="Bullets 3"/>
+          <p:cNvSpPr txBox="1"/>
+          <p:nvPr/>
+        </p:nvSpPr>
+        <p:spPr>
+          <a:xfrm>
+            <a:off x="685800" y="1143000"/>
+            <a:ext cx="10607040" cy="4389120"/>
+          </a:xfrm>
+          <a:prstGeom prst="rect">
+            <a:avLst/>
+          </a:prstGeom>
+          <a:noFill/>
+        </p:spPr>
+        <p:txBody>
+          <a:bodyPr wrap="square"/>
+          <a:lstStyle/>
+          <a:p>
+            <a:pPr marL="342900" indent="-171450">
+              <a:buChar char="•"/>
+            </a:pPr>
+            <a:r>
+              <a:rPr lang="zh-CN" sz="2000">
+                <a:solidFill>
+                  <a:srgbClr val="374151"/>
+                </a:solidFill>
+                <a:latin typeface="Arial"/>
+                <a:ea typeface="Microsoft YaHei"/>
+              </a:rPr>
+              <a:t>5/20–5/22：完成 Home Credit 授权下载；若仍失败，作为补充项。</a:t>
+            </a:r>
+          </a:p>
+          <a:p>
+            <a:pPr marL="342900" indent="-171450">
+              <a:buChar char="•"/>
+            </a:pPr>
+            <a:r>
+              <a:rPr lang="zh-CN" sz="2000">
+                <a:solidFill>
+                  <a:srgbClr val="374151"/>
+                </a:solidFill>
+                <a:latin typeface="Arial"/>
+                <a:ea typeface="Microsoft YaHei"/>
+              </a:rPr>
+              <a:t>5/22–5/27：下载 ACS/Fed 数据，统一州代码和年份/季度口径。</a:t>
+            </a:r>
+          </a:p>
+          <a:p>
+            <a:pPr marL="342900" indent="-171450">
+              <a:buChar char="•"/>
+            </a:pPr>
+            <a:r>
+              <a:rPr lang="zh-CN" sz="2000">
+                <a:solidFill>
+                  <a:srgbClr val="374151"/>
+                </a:solidFill>
+                <a:latin typeface="Arial"/>
+                <a:ea typeface="Microsoft YaHei"/>
+              </a:rPr>
+              <a:t>5/27–6/3：Lending Club 与 ACS/Fed 做州级、时间级融合。</a:t>
+            </a:r>
+          </a:p>
+          <a:p>
+            <a:pPr marL="342900" indent="-171450">
+              <a:buChar char="•"/>
+            </a:pPr>
+            <a:r>
+              <a:rPr lang="zh-CN" sz="2000">
+                <a:solidFill>
+                  <a:srgbClr val="374151"/>
+                </a:solidFill>
+                <a:latin typeface="Arial"/>
+                <a:ea typeface="Microsoft YaHei"/>
+              </a:rPr>
+              <a:t>6/3–6/8：完成最终可视化、核心结论和报告初稿。</a:t>
+            </a:r>
+          </a:p>
+          <a:p>
+            <a:pPr marL="342900" indent="-171450">
+              <a:buChar char="•"/>
+            </a:pPr>
+            <a:r>
+              <a:rPr lang="zh-CN" sz="2000">
+                <a:solidFill>
+                  <a:srgbClr val="374151"/>
+                </a:solidFill>
+                <a:latin typeface="Arial"/>
+                <a:ea typeface="Microsoft YaHei"/>
+              </a:rPr>
+              <a:t>6/8–6/17：打磨最终 PPT、报告、视频和代码仓库。</a:t>
+            </a:r>
+          </a:p>
+        </p:txBody>
+      </p:sp>
+    </p:spTree>
+  </p:cSld>
+  <p:clrMapOvr>
+    <a:masterClrMapping/>
+  </p:clrMapOvr>
+</p:sld>
+</file>
+
+<file path=ppt/slides/slide16.xml><?xml version="1.0" encoding="utf-8"?>
+<p:sld xmlns:a="http://schemas.openxmlformats.org/drawingml/2006/main" xmlns:r="http://schemas.openxmlformats.org/officeDocument/2006/relationships" xmlns:p="http://schemas.openxmlformats.org/presentationml/2006/main">
+  <p:cSld>
+    <p:spTree>
+      <p:nvGrpSpPr>
+        <p:cNvPr id="1" name=""/>
+        <p:cNvGrpSpPr/>
+        <p:nvPr/>
+      </p:nvGrpSpPr>
+      <p:grpSpPr>
+        <a:xfrm>
+          <a:off x="0" y="0"/>
+          <a:ext cx="0" cy="0"/>
+          <a:chOff x="0" y="0"/>
+          <a:chExt cx="0" cy="0"/>
+        </a:xfrm>
+      </p:grpSpPr>
+      <p:sp>
+        <p:nvSpPr>
+          <p:cNvPr id="2" name="TextBox 2"/>
+          <p:cNvSpPr txBox="1"/>
+          <p:nvPr/>
+        </p:nvSpPr>
+        <p:spPr>
+          <a:xfrm>
+            <a:off x="502920" y="292608"/>
+            <a:ext cx="11155680" cy="685800"/>
+          </a:xfrm>
+          <a:prstGeom prst="rect">
+            <a:avLst/>
+          </a:prstGeom>
+          <a:noFill/>
+        </p:spPr>
+        <p:txBody>
+          <a:bodyPr wrap="square"/>
+          <a:lstStyle/>
+          <a:p>
+            <a:r>
+              <a:rPr lang="zh-CN" sz="3000" b="1">
+                <a:solidFill>
+                  <a:srgbClr val="111827"/>
+                </a:solidFill>
+                <a:latin typeface="Arial"/>
+                <a:ea typeface="Microsoft YaHei"/>
+              </a:rPr>
+              <a:t>风险与备选方案</a:t>
+            </a:r>
+          </a:p>
+        </p:txBody>
+      </p:sp>
+      <p:sp>
+        <p:nvSpPr>
+          <p:cNvPr id="3" name="Bullets 3"/>
+          <p:cNvSpPr txBox="1"/>
+          <p:nvPr/>
+        </p:nvSpPr>
+        <p:spPr>
+          <a:xfrm>
+            <a:off x="685800" y="1143000"/>
+            <a:ext cx="10607040" cy="4389120"/>
+          </a:xfrm>
+          <a:prstGeom prst="rect">
+            <a:avLst/>
+          </a:prstGeom>
+          <a:noFill/>
+        </p:spPr>
+        <p:txBody>
+          <a:bodyPr wrap="square"/>
+          <a:lstStyle/>
+          <a:p>
+            <a:pPr marL="342900" indent="-171450">
+              <a:buChar char="•"/>
+            </a:pPr>
+            <a:r>
+              <a:rPr lang="zh-CN" sz="2000">
+                <a:solidFill>
+                  <a:srgbClr val="374151"/>
+                </a:solidFill>
+                <a:latin typeface="Arial"/>
+                <a:ea typeface="Microsoft YaHei"/>
+              </a:rPr>
+              <a:t>Home Credit 需网页授权：先以 Lending Club + ACS + Fed 完成主线。</a:t>
+            </a:r>
+          </a:p>
+          <a:p>
+            <a:pPr marL="342900" indent="-171450">
+              <a:buChar char="•"/>
+            </a:pPr>
+            <a:r>
+              <a:rPr lang="zh-CN" sz="2000">
+                <a:solidFill>
+                  <a:srgbClr val="374151"/>
+                </a:solidFill>
+                <a:latin typeface="Arial"/>
+                <a:ea typeface="Microsoft YaHei"/>
+              </a:rPr>
+              <a:t>ACS/Fed 粒度不一致：降到州级、年度/季度级对齐。</a:t>
+            </a:r>
+          </a:p>
+          <a:p>
+            <a:pPr marL="342900" indent="-171450">
+              <a:buChar char="•"/>
+            </a:pPr>
+            <a:r>
+              <a:rPr lang="zh-CN" sz="2000">
+                <a:solidFill>
+                  <a:srgbClr val="374151"/>
+                </a:solidFill>
+                <a:latin typeface="Arial"/>
+                <a:ea typeface="Microsoft YaHei"/>
+              </a:rPr>
+              <a:t>本地处理大文件慢：继续使用流式 CSV 统计和抽样分析。</a:t>
+            </a:r>
+          </a:p>
+          <a:p>
+            <a:pPr marL="342900" indent="-171450">
+              <a:buChar char="•"/>
+            </a:pPr>
+            <a:r>
+              <a:rPr lang="zh-CN" sz="2000">
+                <a:solidFill>
+                  <a:srgbClr val="374151"/>
+                </a:solidFill>
+                <a:latin typeface="Arial"/>
+                <a:ea typeface="Microsoft YaHei"/>
+              </a:rPr>
+              <a:t>多源变量提升不明显：强调解释性洞察，报告变量边际贡献和局限。</a:t>
+            </a:r>
+          </a:p>
+        </p:txBody>
+      </p:sp>
+    </p:spTree>
+  </p:cSld>
+  <p:clrMapOvr>
+    <a:masterClrMapping/>
+  </p:clrMapOvr>
+</p:sld>
+</file>
+
+<file path=ppt/slides/slide17.xml><?xml version="1.0" encoding="utf-8"?>
+<p:sld xmlns:a="http://schemas.openxmlformats.org/drawingml/2006/main" xmlns:r="http://schemas.openxmlformats.org/officeDocument/2006/relationships" xmlns:p="http://schemas.openxmlformats.org/presentationml/2006/main">
+  <p:cSld>
+    <p:spTree>
+      <p:nvGrpSpPr>
+        <p:cNvPr id="1" name=""/>
+        <p:cNvGrpSpPr/>
+        <p:nvPr/>
+      </p:nvGrpSpPr>
+      <p:grpSpPr>
+        <a:xfrm>
+          <a:off x="0" y="0"/>
+          <a:ext cx="0" cy="0"/>
+          <a:chOff x="0" y="0"/>
+          <a:chExt cx="0" cy="0"/>
+        </a:xfrm>
+      </p:grpSpPr>
+      <p:sp>
+        <p:nvSpPr>
+          <p:cNvPr id="2" name="TextBox 2"/>
+          <p:cNvSpPr txBox="1"/>
+          <p:nvPr/>
+        </p:nvSpPr>
+        <p:spPr>
+          <a:xfrm>
+            <a:off x="502920" y="292608"/>
+            <a:ext cx="11155680" cy="685800"/>
+          </a:xfrm>
+          <a:prstGeom prst="rect">
+            <a:avLst/>
+          </a:prstGeom>
+          <a:noFill/>
+        </p:spPr>
+        <p:txBody>
+          <a:bodyPr wrap="square"/>
+          <a:lstStyle/>
+          <a:p>
+            <a:r>
+              <a:rPr lang="zh-CN" sz="3000" b="1">
+                <a:solidFill>
+                  <a:srgbClr val="111827"/>
+                </a:solidFill>
+                <a:latin typeface="Arial"/>
+                <a:ea typeface="Microsoft YaHei"/>
+              </a:rPr>
+              <a:t>总结</a:t>
+            </a:r>
+          </a:p>
+        </p:txBody>
+      </p:sp>
+      <p:sp>
+        <p:nvSpPr>
+          <p:cNvPr id="3" name="Bullets 3"/>
+          <p:cNvSpPr txBox="1"/>
+          <p:nvPr/>
+        </p:nvSpPr>
+        <p:spPr>
+          <a:xfrm>
+            <a:off x="685800" y="1143000"/>
+            <a:ext cx="10607040" cy="4389120"/>
+          </a:xfrm>
+          <a:prstGeom prst="rect">
+            <a:avLst/>
+          </a:prstGeom>
+          <a:noFill/>
+        </p:spPr>
+        <p:txBody>
+          <a:bodyPr wrap="square"/>
+          <a:lstStyle/>
+          <a:p>
+            <a:pPr marL="342900" indent="-171450">
+              <a:buChar char="•"/>
+            </a:pPr>
+            <a:r>
+              <a:rPr lang="zh-CN" sz="2000">
+                <a:solidFill>
+                  <a:srgbClr val="374151"/>
+                </a:solidFill>
+                <a:latin typeface="Arial"/>
+                <a:ea typeface="Microsoft YaHei"/>
+              </a:rPr>
+              <a:t>中期阶段已经完成真实 Lending Club 数据分析。</a:t>
+            </a:r>
+          </a:p>
+          <a:p>
+            <a:pPr marL="342900" indent="-171450">
+              <a:buChar char="•"/>
+            </a:pPr>
+            <a:r>
+              <a:rPr lang="zh-CN" sz="2000">
+                <a:solidFill>
+                  <a:srgbClr val="374151"/>
+                </a:solidFill>
+                <a:latin typeface="Arial"/>
+                <a:ea typeface="Microsoft YaHei"/>
+              </a:rPr>
+              <a:t>当前已有可复现代码、GitHub 仓库、统计表和真实图表。</a:t>
+            </a:r>
+          </a:p>
+          <a:p>
+            <a:pPr marL="342900" indent="-171450">
+              <a:buChar char="•"/>
+            </a:pPr>
+            <a:r>
+              <a:rPr lang="zh-CN" sz="2000">
+                <a:solidFill>
+                  <a:srgbClr val="374151"/>
+                </a:solidFill>
+                <a:latin typeface="Arial"/>
+                <a:ea typeface="Microsoft YaHei"/>
+              </a:rPr>
+              <a:t>核心初步结论：等级、利率、FICO、地区都与违约风险存在显著关联。</a:t>
+            </a:r>
+          </a:p>
+          <a:p>
+            <a:pPr marL="342900" indent="-171450">
+              <a:buChar char="•"/>
+            </a:pPr>
+            <a:r>
+              <a:rPr lang="zh-CN" sz="2000">
+                <a:solidFill>
+                  <a:srgbClr val="374151"/>
+                </a:solidFill>
+                <a:latin typeface="Arial"/>
+                <a:ea typeface="Microsoft YaHei"/>
+              </a:rPr>
+              <a:t>下一阶段重点：接入 ACS/Fed，解释地区和宏观环境如何影响违约风险。</a:t>
             </a:r>
           </a:p>
         </p:txBody>
@@ -807,7 +1411,7 @@
                 <a:latin typeface="Arial"/>
                 <a:ea typeface="Microsoft YaHei"/>
               </a:rPr>
-              <a:t>研究动机：为什么需要多源风险检测</a:t>
+              <a:t>研究动机：贷款违约不只是个人问题</a:t>
             </a:r>
           </a:p>
         </p:txBody>
@@ -858,22 +1462,22 @@
                 <a:latin typeface="Arial"/>
                 <a:ea typeface="Microsoft YaHei"/>
               </a:rPr>
-              <a:t>传统信用评估主要依赖个人信用与贷款记录，容易忽略环境因素。</a:t>
-            </a:r>
-          </a:p>
-          <a:p>
-            <a:pPr marL="342900" indent="-171450">
-              <a:buChar char="•"/>
-            </a:pPr>
-            <a:r>
-              <a:rPr lang="zh-CN" sz="2000">
-                <a:solidFill>
-                  <a:srgbClr val="374151"/>
-                </a:solidFill>
-                <a:latin typeface="Arial"/>
-                <a:ea typeface="Microsoft YaHei"/>
-              </a:rPr>
-              <a:t>核心观点：违约风险不仅由个人决定，也受到地区经济与宏观金融周期影响。</a:t>
+              <a:t>同样收入和信用等级的人，在不同地区经济环境、利率周期下可能有不同违约概率。</a:t>
+            </a:r>
+          </a:p>
+          <a:p>
+            <a:pPr marL="342900" indent="-171450">
+              <a:buChar char="•"/>
+            </a:pPr>
+            <a:r>
+              <a:rPr lang="zh-CN" sz="2000">
+                <a:solidFill>
+                  <a:srgbClr val="374151"/>
+                </a:solidFill>
+                <a:latin typeface="Arial"/>
+                <a:ea typeface="Microsoft YaHei"/>
+              </a:rPr>
+              <a:t>核心问题：能否用个人信贷 + 地区经济 + 宏观金融数据，形成更可靠、更可解释的风险洞察？</a:t>
             </a:r>
           </a:p>
         </p:txBody>
@@ -931,7 +1535,7 @@
                 <a:latin typeface="Arial"/>
                 <a:ea typeface="Microsoft YaHei"/>
               </a:rPr>
-              <a:t>研究问题</a:t>
+              <a:t>项目挑战：真实金融数据为什么难</a:t>
             </a:r>
           </a:p>
         </p:txBody>
@@ -967,37 +1571,52 @@
                 <a:latin typeface="Arial"/>
                 <a:ea typeface="Microsoft YaHei"/>
               </a:rPr>
-              <a:t>如何整合个人信贷、地区经济与宏观金融数据？</a:t>
-            </a:r>
-          </a:p>
-          <a:p>
-            <a:pPr marL="342900" indent="-171450">
-              <a:buChar char="•"/>
-            </a:pPr>
-            <a:r>
-              <a:rPr lang="zh-CN" sz="2000">
-                <a:solidFill>
-                  <a:srgbClr val="374151"/>
-                </a:solidFill>
-                <a:latin typeface="Arial"/>
-                <a:ea typeface="Microsoft YaHei"/>
-              </a:rPr>
-              <a:t>如何解决多源异构数据在时间和空间粒度上的对齐问题？</a:t>
-            </a:r>
-          </a:p>
-          <a:p>
-            <a:pPr marL="342900" indent="-171450">
-              <a:buChar char="•"/>
-            </a:pPr>
-            <a:r>
-              <a:rPr lang="zh-CN" sz="2000">
-                <a:solidFill>
-                  <a:srgbClr val="374151"/>
-                </a:solidFill>
-                <a:latin typeface="Arial"/>
-                <a:ea typeface="Microsoft YaHei"/>
-              </a:rPr>
-              <a:t>多源变量是否能提供比单一贷款数据更可靠、更可解释的风险洞察？</a:t>
+              <a:t>数据规模大：Lending Club accepted 数据 2,260,701 条、151 个字段。</a:t>
+            </a:r>
+          </a:p>
+          <a:p>
+            <a:pPr marL="342900" indent="-171450">
+              <a:buChar char="•"/>
+            </a:pPr>
+            <a:r>
+              <a:rPr lang="zh-CN" sz="2000">
+                <a:solidFill>
+                  <a:srgbClr val="374151"/>
+                </a:solidFill>
+                <a:latin typeface="Arial"/>
+                <a:ea typeface="Microsoft YaHei"/>
+              </a:rPr>
+              <a:t>标签复杂：Current 等未完结贷款不能简单视为不违约。</a:t>
+            </a:r>
+          </a:p>
+          <a:p>
+            <a:pPr marL="342900" indent="-171450">
+              <a:buChar char="•"/>
+            </a:pPr>
+            <a:r>
+              <a:rPr lang="zh-CN" sz="2000">
+                <a:solidFill>
+                  <a:srgbClr val="374151"/>
+                </a:solidFill>
+                <a:latin typeface="Arial"/>
+                <a:ea typeface="Microsoft YaHei"/>
+              </a:rPr>
+              <a:t>多源融合难：贷款是个人/时间粒度，ACS 是地区粒度，Fed 是宏观时间序列。</a:t>
+            </a:r>
+          </a:p>
+          <a:p>
+            <a:pPr marL="342900" indent="-171450">
+              <a:buChar char="•"/>
+            </a:pPr>
+            <a:r>
+              <a:rPr lang="zh-CN" sz="2000">
+                <a:solidFill>
+                  <a:srgbClr val="374151"/>
+                </a:solidFill>
+                <a:latin typeface="Arial"/>
+                <a:ea typeface="Microsoft YaHei"/>
+              </a:rPr>
+              <a:t>解释性要求高：不仅要算出结果，还要讲清楚为什么。</a:t>
             </a:r>
           </a:p>
         </p:txBody>
@@ -1055,7 +1674,7 @@
                 <a:latin typeface="Arial"/>
                 <a:ea typeface="Microsoft YaHei"/>
               </a:rPr>
-              <a:t>相关工作与项目定位</a:t>
+              <a:t>相关工作与局限</a:t>
             </a:r>
           </a:p>
         </p:txBody>
@@ -1091,37 +1710,52 @@
                 <a:latin typeface="Arial"/>
                 <a:ea typeface="Microsoft YaHei"/>
               </a:rPr>
-              <a:t>传统信用评分关注 FICO、收入、负债率和信用历史。</a:t>
-            </a:r>
-          </a:p>
-          <a:p>
-            <a:pPr marL="342900" indent="-171450">
-              <a:buChar char="•"/>
-            </a:pPr>
-            <a:r>
-              <a:rPr lang="zh-CN" sz="2000">
-                <a:solidFill>
-                  <a:srgbClr val="374151"/>
-                </a:solidFill>
-                <a:latin typeface="Arial"/>
-                <a:ea typeface="Microsoft YaHei"/>
-              </a:rPr>
-              <a:t>机器学习违约预测强调分类效果，但解释性和数据来源常被弱化。</a:t>
-            </a:r>
-          </a:p>
-          <a:p>
-            <a:pPr marL="342900" indent="-171450">
-              <a:buChar char="•"/>
-            </a:pPr>
-            <a:r>
-              <a:rPr lang="zh-CN" sz="2000">
-                <a:solidFill>
-                  <a:srgbClr val="374151"/>
-                </a:solidFill>
-                <a:latin typeface="Arial"/>
-                <a:ea typeface="Microsoft YaHei"/>
-              </a:rPr>
-              <a:t>本项目重点展示真实数据获取、清洗、融合、统计分析和可解释洞察。</a:t>
+              <a:t>传统信用评分：FICO、收入、负债率，解释性强但偏重个体信息。</a:t>
+            </a:r>
+          </a:p>
+          <a:p>
+            <a:pPr marL="342900" indent="-171450">
+              <a:buChar char="•"/>
+            </a:pPr>
+            <a:r>
+              <a:rPr lang="zh-CN" sz="2000">
+                <a:solidFill>
+                  <a:srgbClr val="374151"/>
+                </a:solidFill>
+                <a:latin typeface="Arial"/>
+                <a:ea typeface="Microsoft YaHei"/>
+              </a:rPr>
+              <a:t>机器学习违约预测：Logistic Regression、Random Forest、XGBoost，预测强但容易黑盒化。</a:t>
+            </a:r>
+          </a:p>
+          <a:p>
+            <a:pPr marL="342900" indent="-171450">
+              <a:buChar char="•"/>
+            </a:pPr>
+            <a:r>
+              <a:rPr lang="zh-CN" sz="2000">
+                <a:solidFill>
+                  <a:srgbClr val="374151"/>
+                </a:solidFill>
+                <a:latin typeface="Arial"/>
+                <a:ea typeface="Microsoft YaHei"/>
+              </a:rPr>
+              <a:t>多源金融风险分析：加入地区收入、失业率、利率、通胀，但数据对齐和口径一致性困难。</a:t>
+            </a:r>
+          </a:p>
+          <a:p>
+            <a:pPr marL="342900" indent="-171450">
+              <a:buChar char="•"/>
+            </a:pPr>
+            <a:r>
+              <a:rPr lang="zh-CN" sz="2000">
+                <a:solidFill>
+                  <a:srgbClr val="374151"/>
+                </a:solidFill>
+                <a:latin typeface="Arial"/>
+                <a:ea typeface="Microsoft YaHei"/>
+              </a:rPr>
+              <a:t>本项目定位：先完成真实数据清洗、融合、统计分析和可解释洞察。</a:t>
             </a:r>
           </a:p>
         </p:txBody>
@@ -1179,7 +1813,7 @@
                 <a:latin typeface="Arial"/>
                 <a:ea typeface="Microsoft YaHei"/>
               </a:rPr>
-              <a:t>数据集与当前状态</a:t>
+              <a:t>数据集与中期状态</a:t>
             </a:r>
           </a:p>
         </p:txBody>
@@ -1215,67 +1849,52 @@
                 <a:latin typeface="Arial"/>
                 <a:ea typeface="Microsoft YaHei"/>
               </a:rPr>
-              <a:t>Lending Club：贷款状态、等级、利率、收入、州、发放时间；待手动下载。</a:t>
-            </a:r>
-          </a:p>
-          <a:p>
-            <a:pPr marL="342900" indent="-171450">
-              <a:buChar char="•"/>
-            </a:pPr>
-            <a:r>
-              <a:rPr lang="zh-CN" sz="2000">
-                <a:solidFill>
-                  <a:srgbClr val="374151"/>
-                </a:solidFill>
-                <a:latin typeface="Arial"/>
-                <a:ea typeface="Microsoft YaHei"/>
-              </a:rPr>
-              <a:t>Home Credit：信贷申请人与历史特征；作为补充对照数据。</a:t>
-            </a:r>
-          </a:p>
-          <a:p>
-            <a:pPr marL="342900" indent="-171450">
-              <a:buChar char="•"/>
-            </a:pPr>
-            <a:r>
-              <a:rPr lang="zh-CN" sz="2000">
-                <a:solidFill>
-                  <a:srgbClr val="374151"/>
-                </a:solidFill>
-                <a:latin typeface="Arial"/>
-                <a:ea typeface="Microsoft YaHei"/>
-              </a:rPr>
-              <a:t>ACS：州/县级收入、贫困率、就业等区域变量。</a:t>
-            </a:r>
-          </a:p>
-          <a:p>
-            <a:pPr marL="342900" indent="-171450">
-              <a:buChar char="•"/>
-            </a:pPr>
-            <a:r>
-              <a:rPr lang="zh-CN" sz="2000">
-                <a:solidFill>
-                  <a:srgbClr val="374151"/>
-                </a:solidFill>
-                <a:latin typeface="Arial"/>
-                <a:ea typeface="Microsoft YaHei"/>
-              </a:rPr>
-              <a:t>Fed：利率、通胀等宏观变量。</a:t>
-            </a:r>
-          </a:p>
-          <a:p>
-            <a:pPr marL="342900" indent="-171450">
-              <a:buChar char="•"/>
-            </a:pPr>
-            <a:r>
-              <a:rPr lang="zh-CN" sz="2000">
-                <a:solidFill>
-                  <a:srgbClr val="374151"/>
-                </a:solidFill>
-                <a:latin typeface="Arial"/>
-                <a:ea typeface="Microsoft YaHei"/>
-              </a:rPr>
-              <a:t>中期已完成脚本接入约定和样例多源流程。</a:t>
+              <a:t>Lending Club：已下载并完成真实数据初步分析。</a:t>
+            </a:r>
+          </a:p>
+          <a:p>
+            <a:pPr marL="342900" indent="-171450">
+              <a:buChar char="•"/>
+            </a:pPr>
+            <a:r>
+              <a:rPr lang="zh-CN" sz="2000">
+                <a:solidFill>
+                  <a:srgbClr val="374151"/>
+                </a:solidFill>
+                <a:latin typeface="Arial"/>
+                <a:ea typeface="Microsoft YaHei"/>
+              </a:rPr>
+              <a:t>Home Credit：Kaggle competition 需网页端接受 rules 后继续下载。</a:t>
+            </a:r>
+          </a:p>
+          <a:p>
+            <a:pPr marL="342900" indent="-171450">
+              <a:buChar char="•"/>
+            </a:pPr>
+            <a:r>
+              <a:rPr lang="zh-CN" sz="2000">
+                <a:solidFill>
+                  <a:srgbClr val="374151"/>
+                </a:solidFill>
+                <a:latin typeface="Arial"/>
+                <a:ea typeface="Microsoft YaHei"/>
+              </a:rPr>
+              <a:t>ACS 区域经济数据：下一阶段接入州/县级收入、贫困率、就业等变量。</a:t>
+            </a:r>
+          </a:p>
+          <a:p>
+            <a:pPr marL="342900" indent="-171450">
+              <a:buChar char="•"/>
+            </a:pPr>
+            <a:r>
+              <a:rPr lang="zh-CN" sz="2000">
+                <a:solidFill>
+                  <a:srgbClr val="374151"/>
+                </a:solidFill>
+                <a:latin typeface="Arial"/>
+                <a:ea typeface="Microsoft YaHei"/>
+              </a:rPr>
+              <a:t>Fed 宏观金融数据：下一阶段接入利率、通胀、失业率等变量。</a:t>
             </a:r>
           </a:p>
         </p:txBody>
@@ -1369,67 +1988,67 @@
                 <a:latin typeface="Arial"/>
                 <a:ea typeface="Microsoft YaHei"/>
               </a:rPr>
-              <a:t>数据获取：Kaggle 手动下载，ACS/Fed 外部数据后续接入。</a:t>
-            </a:r>
-          </a:p>
-          <a:p>
-            <a:pPr marL="342900" indent="-171450">
-              <a:buChar char="•"/>
-            </a:pPr>
-            <a:r>
-              <a:rPr lang="zh-CN" sz="2000">
-                <a:solidFill>
-                  <a:srgbClr val="374151"/>
-                </a:solidFill>
-                <a:latin typeface="Arial"/>
-                <a:ea typeface="Microsoft YaHei"/>
-              </a:rPr>
-              <a:t>数据探索：规模、字段、缺失值、标签分布。</a:t>
-            </a:r>
-          </a:p>
-          <a:p>
-            <a:pPr marL="342900" indent="-171450">
-              <a:buChar char="•"/>
-            </a:pPr>
-            <a:r>
-              <a:rPr lang="zh-CN" sz="2000">
-                <a:solidFill>
-                  <a:srgbClr val="374151"/>
-                </a:solidFill>
-                <a:latin typeface="Arial"/>
-                <a:ea typeface="Microsoft YaHei"/>
-              </a:rPr>
-              <a:t>数据清洗：字段标准化、缺失值统计、异常值检查。</a:t>
-            </a:r>
-          </a:p>
-          <a:p>
-            <a:pPr marL="342900" indent="-171450">
-              <a:buChar char="•"/>
-            </a:pPr>
-            <a:r>
-              <a:rPr lang="zh-CN" sz="2000">
-                <a:solidFill>
-                  <a:srgbClr val="374151"/>
-                </a:solidFill>
-                <a:latin typeface="Arial"/>
-                <a:ea typeface="Microsoft YaHei"/>
-              </a:rPr>
-              <a:t>多源融合：按州连接区域经济数据，按年份连接宏观数据。</a:t>
-            </a:r>
-          </a:p>
-          <a:p>
-            <a:pPr marL="342900" indent="-171450">
-              <a:buChar char="•"/>
-            </a:pPr>
-            <a:r>
-              <a:rPr lang="zh-CN" sz="2000">
-                <a:solidFill>
-                  <a:srgbClr val="374151"/>
-                </a:solidFill>
-                <a:latin typeface="Arial"/>
-                <a:ea typeface="Microsoft YaHei"/>
-              </a:rPr>
-              <a:t>SQL 聚合与可视化：输出表格和 PNG 图表。</a:t>
+              <a:t>Kaggle 原始数据下载到 data/raw，不上传 GitHub。</a:t>
+            </a:r>
+          </a:p>
+          <a:p>
+            <a:pPr marL="342900" indent="-171450">
+              <a:buChar char="•"/>
+            </a:pPr>
+            <a:r>
+              <a:rPr lang="zh-CN" sz="2000">
+                <a:solidFill>
+                  <a:srgbClr val="374151"/>
+                </a:solidFill>
+                <a:latin typeface="Arial"/>
+                <a:ea typeface="Microsoft YaHei"/>
+              </a:rPr>
+              <a:t>字段检查与缺失率统计。</a:t>
+            </a:r>
+          </a:p>
+          <a:p>
+            <a:pPr marL="342900" indent="-171450">
+              <a:buChar char="•"/>
+            </a:pPr>
+            <a:r>
+              <a:rPr lang="zh-CN" sz="2000">
+                <a:solidFill>
+                  <a:srgbClr val="374151"/>
+                </a:solidFill>
+                <a:latin typeface="Arial"/>
+                <a:ea typeface="Microsoft YaHei"/>
+              </a:rPr>
+              <a:t>贷款状态过滤：保留 Fully Paid / Charged Off / Default 等可判断最终结果的状态。</a:t>
+            </a:r>
+          </a:p>
+          <a:p>
+            <a:pPr marL="342900" indent="-171450">
+              <a:buChar char="•"/>
+            </a:pPr>
+            <a:r>
+              <a:rPr lang="zh-CN" sz="2000">
+                <a:solidFill>
+                  <a:srgbClr val="374151"/>
+                </a:solidFill>
+                <a:latin typeface="Arial"/>
+                <a:ea typeface="Microsoft YaHei"/>
+              </a:rPr>
+              <a:t>按等级、年份、州、利率、收入、DTI、FICO 聚合违约率。</a:t>
+            </a:r>
+          </a:p>
+          <a:p>
+            <a:pPr marL="342900" indent="-171450">
+              <a:buChar char="•"/>
+            </a:pPr>
+            <a:r>
+              <a:rPr lang="zh-CN" sz="2000">
+                <a:solidFill>
+                  <a:srgbClr val="374151"/>
+                </a:solidFill>
+                <a:latin typeface="Arial"/>
+                <a:ea typeface="Microsoft YaHei"/>
+              </a:rPr>
+              <a:t>输出 CSV 统计表与 PNG 图表，下一阶段接入 ACS/Fed。</a:t>
             </a:r>
           </a:p>
         </p:txBody>
@@ -1487,7 +2106,7 @@
                 <a:latin typeface="Arial"/>
                 <a:ea typeface="Microsoft YaHei"/>
               </a:rPr>
-              <a:t>当前进度</a:t>
+              <a:t>当前进度：已经从框架推进到真实数据</a:t>
             </a:r>
           </a:p>
         </p:txBody>
@@ -1523,67 +2142,67 @@
                 <a:latin typeface="Arial"/>
                 <a:ea typeface="Microsoft YaHei"/>
               </a:rPr>
-              <a:t>已建立可提交代码库结构和 README。</a:t>
-            </a:r>
-          </a:p>
-          <a:p>
-            <a:pPr marL="342900" indent="-171450">
-              <a:buChar char="•"/>
-            </a:pPr>
-            <a:r>
-              <a:rPr lang="zh-CN" sz="2000">
-                <a:solidFill>
-                  <a:srgbClr val="374151"/>
-                </a:solidFill>
-                <a:latin typeface="Arial"/>
-                <a:ea typeface="Microsoft YaHei"/>
-              </a:rPr>
-              <a:t>已提供 Kaggle 数据放置说明。</a:t>
-            </a:r>
-          </a:p>
-          <a:p>
-            <a:pPr marL="342900" indent="-171450">
-              <a:buChar char="•"/>
-            </a:pPr>
-            <a:r>
-              <a:rPr lang="zh-CN" sz="2000">
-                <a:solidFill>
-                  <a:srgbClr val="374151"/>
-                </a:solidFill>
-                <a:latin typeface="Arial"/>
-                <a:ea typeface="Microsoft YaHei"/>
-              </a:rPr>
-              <a:t>已实现 src/run_midterm_pipeline.py。</a:t>
-            </a:r>
-          </a:p>
-          <a:p>
-            <a:pPr marL="342900" indent="-171450">
-              <a:buChar char="•"/>
-            </a:pPr>
-            <a:r>
-              <a:rPr lang="zh-CN" sz="2000">
-                <a:solidFill>
-                  <a:srgbClr val="374151"/>
-                </a:solidFill>
-                <a:latin typeface="Arial"/>
-                <a:ea typeface="Microsoft YaHei"/>
-              </a:rPr>
-              <a:t>无 Kaggle 数据时仍可生成样例融合数据、统计表和图表。</a:t>
-            </a:r>
-          </a:p>
-          <a:p>
-            <a:pPr marL="342900" indent="-171450">
-              <a:buChar char="•"/>
-            </a:pPr>
-            <a:r>
-              <a:rPr lang="zh-CN" sz="2000">
-                <a:solidFill>
-                  <a:srgbClr val="374151"/>
-                </a:solidFill>
-                <a:latin typeface="Arial"/>
-                <a:ea typeface="Microsoft YaHei"/>
-              </a:rPr>
-              <a:t>放入贷款 CSV 后可自动生成贷款概览、缺失率和标签分布。</a:t>
+              <a:t>GitHub 仓库、README、数据说明和运行脚本已完成。</a:t>
+            </a:r>
+          </a:p>
+          <a:p>
+            <a:pPr marL="342900" indent="-171450">
+              <a:buChar char="•"/>
+            </a:pPr>
+            <a:r>
+              <a:rPr lang="zh-CN" sz="2000">
+                <a:solidFill>
+                  <a:srgbClr val="374151"/>
+                </a:solidFill>
+                <a:latin typeface="Arial"/>
+                <a:ea typeface="Microsoft YaHei"/>
+              </a:rPr>
+              <a:t>已读取 2,260,701 条 Lending Club accepted 贷款记录。</a:t>
+            </a:r>
+          </a:p>
+          <a:p>
+            <a:pPr marL="342900" indent="-171450">
+              <a:buChar char="•"/>
+            </a:pPr>
+            <a:r>
+              <a:rPr lang="zh-CN" sz="2000">
+                <a:solidFill>
+                  <a:srgbClr val="374151"/>
+                </a:solidFill>
+                <a:latin typeface="Arial"/>
+                <a:ea typeface="Microsoft YaHei"/>
+              </a:rPr>
+              <a:t>筛选 1,367,578 条已完结记录用于违约率统计。</a:t>
+            </a:r>
+          </a:p>
+          <a:p>
+            <a:pPr marL="342900" indent="-171450">
+              <a:buChar char="•"/>
+            </a:pPr>
+            <a:r>
+              <a:rPr lang="zh-CN" sz="2000">
+                <a:solidFill>
+                  <a:srgbClr val="374151"/>
+                </a:solidFill>
+                <a:latin typeface="Arial"/>
+                <a:ea typeface="Microsoft YaHei"/>
+              </a:rPr>
+              <a:t>已生成真实统计表和图表：等级、利率、FICO、年份、州。</a:t>
+            </a:r>
+          </a:p>
+          <a:p>
+            <a:pPr marL="342900" indent="-171450">
+              <a:buChar char="•"/>
+            </a:pPr>
+            <a:r>
+              <a:rPr lang="zh-CN" sz="2000">
+                <a:solidFill>
+                  <a:srgbClr val="374151"/>
+                </a:solidFill>
+                <a:latin typeface="Arial"/>
+                <a:ea typeface="Microsoft YaHei"/>
+              </a:rPr>
+              <a:t>当前节点：完成单一真实信贷数据源分析，下一步进入多源融合。</a:t>
             </a:r>
           </a:p>
         </p:txBody>
@@ -1641,7 +2260,7 @@
                 <a:latin typeface="Arial"/>
                 <a:ea typeface="Microsoft YaHei"/>
               </a:rPr>
-              <a:t>样例结果：贷款等级与违约率</a:t>
+              <a:t>真实发现 1：贷款等级与违约率</a:t>
             </a:r>
           </a:p>
         </p:txBody>
@@ -1677,37 +2296,52 @@
                 <a:latin typeface="Arial"/>
                 <a:ea typeface="Microsoft YaHei"/>
               </a:rPr>
-              <a:t>按贷款等级聚合样例违约率。</a:t>
-            </a:r>
-          </a:p>
-          <a:p>
-            <a:pPr marL="342900" indent="-171450">
-              <a:buChar char="•"/>
-            </a:pPr>
-            <a:r>
-              <a:rPr lang="zh-CN" sz="2000">
-                <a:solidFill>
-                  <a:srgbClr val="374151"/>
-                </a:solidFill>
-                <a:latin typeface="Arial"/>
-                <a:ea typeface="Microsoft YaHei"/>
-              </a:rPr>
-              <a:t>用于展示未来真实 Lending Club 数据中的信用等级风险分析方式。</a:t>
-            </a:r>
-          </a:p>
-          <a:p>
-            <a:pPr marL="342900" indent="-171450">
-              <a:buChar char="•"/>
-            </a:pPr>
-            <a:r>
-              <a:rPr lang="zh-CN" sz="2000">
-                <a:solidFill>
-                  <a:srgbClr val="374151"/>
-                </a:solidFill>
-                <a:latin typeface="Arial"/>
-                <a:ea typeface="Microsoft YaHei"/>
-              </a:rPr>
-              <a:t>最终结论需在真实数据下载后重新运行生成。</a:t>
+              <a:t>贷款等级风险呈明显梯度。</a:t>
+            </a:r>
+          </a:p>
+          <a:p>
+            <a:pPr marL="342900" indent="-171450">
+              <a:buChar char="•"/>
+            </a:pPr>
+            <a:r>
+              <a:rPr lang="zh-CN" sz="2000">
+                <a:solidFill>
+                  <a:srgbClr val="374151"/>
+                </a:solidFill>
+                <a:latin typeface="Arial"/>
+                <a:ea typeface="Microsoft YaHei"/>
+              </a:rPr>
+              <a:t>A 等级违约率约 6.57%。</a:t>
+            </a:r>
+          </a:p>
+          <a:p>
+            <a:pPr marL="342900" indent="-171450">
+              <a:buChar char="•"/>
+            </a:pPr>
+            <a:r>
+              <a:rPr lang="zh-CN" sz="2000">
+                <a:solidFill>
+                  <a:srgbClr val="374151"/>
+                </a:solidFill>
+                <a:latin typeface="Arial"/>
+                <a:ea typeface="Microsoft YaHei"/>
+              </a:rPr>
+              <a:t>G 等级违约率约 51.57%。</a:t>
+            </a:r>
+          </a:p>
+          <a:p>
+            <a:pPr marL="342900" indent="-171450">
+              <a:buChar char="•"/>
+            </a:pPr>
+            <a:r>
+              <a:rPr lang="zh-CN" sz="2000">
+                <a:solidFill>
+                  <a:srgbClr val="374151"/>
+                </a:solidFill>
+                <a:latin typeface="Arial"/>
+                <a:ea typeface="Microsoft YaHei"/>
+              </a:rPr>
+              <a:t>说明平台等级体系对违约风险有强区分力，是后续多源分析的个体风险基准。</a:t>
             </a:r>
           </a:p>
         </p:txBody>
@@ -1787,7 +2421,7 @@
                 <a:latin typeface="Arial"/>
                 <a:ea typeface="Microsoft YaHei"/>
               </a:rPr>
-              <a:t>样例结果：宏观金融指标趋势</a:t>
+              <a:t>真实发现 2：利率与违约率</a:t>
             </a:r>
           </a:p>
         </p:txBody>
@@ -1823,37 +2457,52 @@
                 <a:latin typeface="Arial"/>
                 <a:ea typeface="Microsoft YaHei"/>
               </a:rPr>
-              <a:t>按年份组织联邦基金利率与通胀率。</a:t>
-            </a:r>
-          </a:p>
-          <a:p>
-            <a:pPr marL="342900" indent="-171450">
-              <a:buChar char="•"/>
-            </a:pPr>
-            <a:r>
-              <a:rPr lang="zh-CN" sz="2000">
-                <a:solidFill>
-                  <a:srgbClr val="374151"/>
-                </a:solidFill>
-                <a:latin typeface="Arial"/>
-                <a:ea typeface="Microsoft YaHei"/>
-              </a:rPr>
-              <a:t>用于说明宏观环境如何进入贷款风险分析框架。</a:t>
-            </a:r>
-          </a:p>
-          <a:p>
-            <a:pPr marL="342900" indent="-171450">
-              <a:buChar char="•"/>
-            </a:pPr>
-            <a:r>
-              <a:rPr lang="zh-CN" sz="2000">
-                <a:solidFill>
-                  <a:srgbClr val="374151"/>
-                </a:solidFill>
-                <a:latin typeface="Arial"/>
-                <a:ea typeface="Microsoft YaHei"/>
-              </a:rPr>
-              <a:t>后续将与真实贷款发放时间进行年度或季度级对齐。</a:t>
+              <a:t>利率越高，违约率越高。</a:t>
+            </a:r>
+          </a:p>
+          <a:p>
+            <a:pPr marL="342900" indent="-171450">
+              <a:buChar char="•"/>
+            </a:pPr>
+            <a:r>
+              <a:rPr lang="zh-CN" sz="2000">
+                <a:solidFill>
+                  <a:srgbClr val="374151"/>
+                </a:solidFill>
+                <a:latin typeface="Arial"/>
+                <a:ea typeface="Microsoft YaHei"/>
+              </a:rPr>
+              <a:t>&lt;8% 利率分箱违约率约 6.38%。</a:t>
+            </a:r>
+          </a:p>
+          <a:p>
+            <a:pPr marL="342900" indent="-171450">
+              <a:buChar char="•"/>
+            </a:pPr>
+            <a:r>
+              <a:rPr lang="zh-CN" sz="2000">
+                <a:solidFill>
+                  <a:srgbClr val="374151"/>
+                </a:solidFill>
+                <a:latin typeface="Arial"/>
+                <a:ea typeface="Microsoft YaHei"/>
+              </a:rPr>
+              <a:t>&gt;=24% 利率分箱违约率约 48.56%。</a:t>
+            </a:r>
+          </a:p>
+          <a:p>
+            <a:pPr marL="342900" indent="-171450">
+              <a:buChar char="•"/>
+            </a:pPr>
+            <a:r>
+              <a:rPr lang="zh-CN" sz="2000">
+                <a:solidFill>
+                  <a:srgbClr val="374151"/>
+                </a:solidFill>
+                <a:latin typeface="Arial"/>
+                <a:ea typeface="Microsoft YaHei"/>
+              </a:rPr>
+              <a:t>说明定价包含风险补偿，但高风险贷款仍有明显违约集中。</a:t>
             </a:r>
           </a:p>
         </p:txBody>

</xml_diff>